<commit_message>
Day 2 Session 3: map reviewer answers on the existing @aicaravan_bot
Switch script (tools/aicaravan-bot.sh, installed on the course server) moves the
bot between the Day 1 profile and the mapreview profile; deck, worksheet, guide and
setup sheet updated; Join slide reuses the Day 1 QR.

Co-Authored-By: Claude Opus 5.5 <noreply@anthropic.com>
</commit_message>
<xml_diff>
--- a/instructor/ai-administrator/out/day2/Day2_S3_Mapping_Current_State.pptx
+++ b/instructor/ai-administrator/out/day2/Day2_S3_Mapping_Current_State.pptx
@@ -2226,7 +2226,7 @@
           <a:lstStyle/>
           <a:p>
             <a:r>
-              <a:t>Check the reviewer is running (setup guide). Share the worksheet PDF in the chat. Same server as the Day 1 agent, a different job: it only reviews maps.</a:t>
+              <a:t>Check aicaravan-bot status says mapreview (setup guide). Share the worksheet PDF in the chat. Same bot and server as the Day 1 agent, a different job today: it only reviews maps.</a:t>
             </a:r>
           </a:p>
         </p:txBody>
@@ -2366,7 +2366,7 @@
           <a:lstStyle/>
           <a:p>
             <a:r>
-              <a:t>Three minutes. Pair anyone without Telegram with a neighbour.</a:t>
+              <a:t>Three minutes. It is the same @aicaravan_bot as Day 1, switched to the reviewer job for this session (setup guide: aicaravan-bot mapreview). Participants who already chatted with it on Day 1 just send a new message. Pair anyone without Telegram with a neighbour.</a:t>
             </a:r>
           </a:p>
         </p:txBody>
@@ -17136,7 +17136,7 @@
                 </a:solidFill>
                 <a:latin typeface="Calibri"/>
               </a:rPr>
-              <a:t>•  Like Session 2's policy bot: one job, written into its instructions</a:t>
+              <a:t>•  Same bot as Day 1, new job: today its instructions say review maps, nothing else</a:t>
             </a:r>
           </a:p>
         </p:txBody>
@@ -17396,91 +17396,33 @@
           </a:p>
         </p:txBody>
       </p:sp>
-      <p:sp>
-        <p:nvSpPr>
-          <p:cNvPr id="5" name="Rectangle 4"/>
-          <p:cNvSpPr/>
-          <p:nvPr/>
-        </p:nvSpPr>
+      <p:pic>
+        <p:nvPicPr>
+          <p:cNvPr id="5" name="Picture 4" descr="bot_qr.png"/>
+          <p:cNvPicPr>
+            <a:picLocks noChangeAspect="1"/>
+          </p:cNvPicPr>
+          <p:nvPr/>
+        </p:nvPicPr>
+        <p:blipFill>
+          <a:blip r:embed="rId2"/>
+          <a:stretch>
+            <a:fillRect/>
+          </a:stretch>
+        </p:blipFill>
         <p:spPr>
           <a:xfrm>
             <a:off x="548640" y="1508760"/>
-            <a:ext cx="3291840" cy="3291840"/>
-          </a:xfrm>
-          <a:prstGeom prst="rect">
-            <a:avLst/>
-          </a:prstGeom>
-          <a:solidFill>
-            <a:srgbClr val="F2F2F2"/>
-          </a:solidFill>
-          <a:ln>
-            <a:solidFill>
-              <a:srgbClr val="666666"/>
-            </a:solidFill>
-            <a:prstDash val="dash"/>
-          </a:ln>
-          <a:effectLst/>
-        </p:spPr>
-        <p:style>
-          <a:lnRef idx="1">
-            <a:schemeClr val="accent1"/>
-          </a:lnRef>
-          <a:fillRef idx="3">
-            <a:schemeClr val="accent1"/>
-          </a:fillRef>
-          <a:effectRef idx="2">
-            <a:schemeClr val="accent1"/>
-          </a:effectRef>
-          <a:fontRef idx="minor">
-            <a:schemeClr val="lt1"/>
-          </a:fontRef>
-        </p:style>
-        <p:txBody>
-          <a:bodyPr rtlCol="0" anchor="ctr"/>
-          <a:lstStyle/>
-          <a:p>
-            <a:pPr algn="ctr"/>
-          </a:p>
-        </p:txBody>
-      </p:sp>
+            <a:ext cx="3291839" cy="3291839"/>
+          </a:xfrm>
+          <a:prstGeom prst="rect">
+            <a:avLst/>
+          </a:prstGeom>
+        </p:spPr>
+      </p:pic>
       <p:sp>
         <p:nvSpPr>
           <p:cNvPr id="6" name="TextBox 5"/>
-          <p:cNvSpPr txBox="1"/>
-          <p:nvPr/>
-        </p:nvSpPr>
-        <p:spPr>
-          <a:xfrm>
-            <a:off x="548640" y="2697480"/>
-            <a:ext cx="3291840" cy="914400"/>
-          </a:xfrm>
-          <a:prstGeom prst="rect">
-            <a:avLst/>
-          </a:prstGeom>
-          <a:noFill/>
-        </p:spPr>
-        <p:txBody>
-          <a:bodyPr wrap="square" anchor="ctr" lIns="45720" rIns="45720" tIns="27432" bIns="27432">
-            <a:spAutoFit/>
-          </a:bodyPr>
-          <a:lstStyle/>
-          <a:p>
-            <a:pPr algn="ctr"/>
-            <a:r>
-              <a:rPr sz="1600" b="0" i="0">
-                <a:solidFill>
-                  <a:srgbClr val="666666"/>
-                </a:solidFill>
-                <a:latin typeface="Calibri"/>
-              </a:rPr>
-              <a:t>Paste the map reviewer bot QR code here (see setup guide)</a:t>
-            </a:r>
-          </a:p>
-        </p:txBody>
-      </p:sp>
-      <p:sp>
-        <p:nvSpPr>
-          <p:cNvPr id="7" name="TextBox 6"/>
           <p:cNvSpPr txBox="1"/>
           <p:nvPr/>
         </p:nvSpPr>
@@ -17508,14 +17450,14 @@
                 </a:solidFill>
                 <a:latin typeface="Calibri"/>
               </a:rPr>
-              <a:t>@aicaravan_mapreview_bot</a:t>
-            </a:r>
-          </a:p>
-        </p:txBody>
-      </p:sp>
-      <p:sp>
-        <p:nvSpPr>
-          <p:cNvPr id="8" name="TextBox 7"/>
+              <a:t>@aicaravan_bot</a:t>
+            </a:r>
+          </a:p>
+        </p:txBody>
+      </p:sp>
+      <p:sp>
+        <p:nvSpPr>
+          <p:cNvPr id="7" name="TextBox 6"/>
           <p:cNvSpPr txBox="1"/>
           <p:nvPr/>
         </p:nvSpPr>
@@ -17550,7 +17492,7 @@
       </p:sp>
       <p:sp>
         <p:nvSpPr>
-          <p:cNvPr id="9" name="TextBox 8"/>
+          <p:cNvPr id="8" name="TextBox 7"/>
           <p:cNvSpPr txBox="1"/>
           <p:nvPr/>
         </p:nvSpPr>
@@ -17621,7 +17563,7 @@
       </p:sp>
       <p:sp>
         <p:nvSpPr>
-          <p:cNvPr id="10" name="TextBox 9"/>
+          <p:cNvPr id="9" name="TextBox 8"/>
           <p:cNvSpPr txBox="1"/>
           <p:nvPr/>
         </p:nvSpPr>
@@ -17656,7 +17598,7 @@
       </p:sp>
       <p:sp>
         <p:nvSpPr>
-          <p:cNvPr id="11" name="TextBox 10"/>
+          <p:cNvPr id="10" name="TextBox 9"/>
           <p:cNvSpPr txBox="1"/>
           <p:nvPr/>
         </p:nvSpPr>
@@ -17727,7 +17669,7 @@
       </p:sp>
       <p:sp>
         <p:nvSpPr>
-          <p:cNvPr id="12" name="Rectangle 11"/>
+          <p:cNvPr id="11" name="Rectangle 10"/>
           <p:cNvSpPr/>
           <p:nvPr/>
         </p:nvSpPr>
@@ -17771,7 +17713,7 @@
       </p:sp>
       <p:sp>
         <p:nvSpPr>
-          <p:cNvPr id="13" name="TextBox 12"/>
+          <p:cNvPr id="12" name="TextBox 11"/>
           <p:cNvSpPr txBox="1"/>
           <p:nvPr/>
         </p:nvSpPr>
@@ -17806,7 +17748,7 @@
       </p:sp>
       <p:sp>
         <p:nvSpPr>
-          <p:cNvPr id="14" name="TextBox 13"/>
+          <p:cNvPr id="13" name="TextBox 12"/>
           <p:cNvSpPr txBox="1"/>
           <p:nvPr/>
         </p:nvSpPr>

</xml_diff>

<commit_message>
AI Administrator Day 2 S3: draw.io and practical videos, licensed photos with credits
- Video 1 (swimlane template) and Video 2 (leave-request map): narrated draw.io screencasts
  driven with real input (video/drawio), synced by an on-screen marker, keyboard deselect
- Practical video: the live map reviewer on @aicaravan_bot doing the three worksheet tasks
- Seven slides get openly licensed Wikimedia Commons images with per-slide credit lines
  and an Image credits slide; build_deck supports per-slide credit and .jpg figures

Co-Authored-By: Claude Opus 5.5 <noreply@anthropic.com>
</commit_message>
<xml_diff>
--- a/instructor/ai-administrator/out/day2/Day2_S3_Mapping_Current_State.pptx
+++ b/instructor/ai-administrator/out/day2/Day2_S3_Mapping_Current_State.pptx
@@ -50,6 +50,7 @@
     <p:sldId id="298" r:id="rId50"/>
     <p:sldId id="299" r:id="rId51"/>
     <p:sldId id="300" r:id="rId52"/>
+    <p:sldId id="301" r:id="rId53"/>
   </p:sldIdLst>
   <p:sldSz cx="12191695" cy="6858000" type="screen4x3"/>
   <p:notesSz cx="6858000" cy="9144000"/>
@@ -3276,7 +3277,77 @@
           <a:lstStyle/>
           <a:p>
             <a:r>
-              <a:t>Leave on screen during questions. All figures were drawn for this course; the leave process and AI Caravan Ltd. are fictional.</a:t>
+              <a:t>Leave on screen during questions. Course figures were drawn for this course (photos: see Image credits); the leave process and AI Caravan Ltd. are fictional.</a:t>
+            </a:r>
+          </a:p>
+        </p:txBody>
+      </p:sp>
+      <p:sp>
+        <p:nvSpPr>
+          <p:cNvPr id="4" name="Slide Number Placeholder 3"/>
+          <p:cNvSpPr>
+            <a:spLocks noGrp="1"/>
+          </p:cNvSpPr>
+          <p:nvPr>
+            <p:ph type="sldNum" idx="5" sz="quarter"/>
+          </p:nvPr>
+        </p:nvSpPr>
+        <p:spPr/>
+      </p:sp>
+    </p:spTree>
+  </p:cSld>
+  <p:clrMapOvr>
+    <a:masterClrMapping/>
+  </p:clrMapOvr>
+</p:notes>
+</file>
+
+<file path=ppt/notesSlides/notesSlide46.xml><?xml version="1.0" encoding="utf-8"?>
+<p:notes xmlns:a="http://schemas.openxmlformats.org/drawingml/2006/main" xmlns:p="http://schemas.openxmlformats.org/presentationml/2006/main" xmlns:r="http://schemas.openxmlformats.org/officeDocument/2006/relationships">
+  <p:cSld>
+    <p:spTree>
+      <p:nvGrpSpPr>
+        <p:cNvPr id="1" name=""/>
+        <p:cNvGrpSpPr/>
+        <p:nvPr/>
+      </p:nvGrpSpPr>
+      <p:grpSpPr>
+        <a:xfrm>
+          <a:off x="0" y="0"/>
+          <a:ext cx="0" cy="0"/>
+          <a:chOff x="0" y="0"/>
+          <a:chExt cx="0" cy="0"/>
+        </a:xfrm>
+      </p:grpSpPr>
+      <p:sp>
+        <p:nvSpPr>
+          <p:cNvPr id="2" name="Slide Image Placeholder 1"/>
+          <p:cNvSpPr>
+            <a:spLocks noGrp="1"/>
+          </p:cNvSpPr>
+          <p:nvPr>
+            <p:ph type="sldImg" idx="2"/>
+          </p:nvPr>
+        </p:nvSpPr>
+        <p:spPr/>
+      </p:sp>
+      <p:sp>
+        <p:nvSpPr>
+          <p:cNvPr id="3" name="Notes Placeholder 2"/>
+          <p:cNvSpPr>
+            <a:spLocks noGrp="1"/>
+          </p:cNvSpPr>
+          <p:nvPr>
+            <p:ph type="body" idx="3" sz="quarter"/>
+          </p:nvPr>
+        </p:nvSpPr>
+        <p:spPr/>
+        <p:txBody>
+          <a:bodyPr/>
+          <a:lstStyle/>
+          <a:p>
+            <a:r>
+              <a:t>Third-party photos and the swimlane example are from Wikimedia Commons under the licences listed; all other figures were drawn for this course. Images were resized; no other changes.</a:t>
             </a:r>
           </a:p>
         </p:txBody>
@@ -8168,8 +8239,8 @@
         </p:nvSpPr>
         <p:spPr>
           <a:xfrm>
-            <a:off x="7071055" y="6016752"/>
-            <a:ext cx="4572000" cy="274320"/>
+            <a:off x="4785055" y="6016752"/>
+            <a:ext cx="6858000" cy="274320"/>
           </a:xfrm>
           <a:prstGeom prst="rect">
             <a:avLst/>
@@ -9546,7 +9617,7 @@
           <a:p>
             <a:pPr algn="l"/>
             <a:r>
-              <a:rPr sz="3000" b="1" i="0">
+              <a:rPr sz="2600" b="1" i="0">
                 <a:solidFill>
                   <a:srgbClr val="111111"/>
                 </a:solidFill>
@@ -9645,16 +9716,40 @@
           </a:p>
         </p:txBody>
       </p:sp>
-      <p:sp>
-        <p:nvSpPr>
-          <p:cNvPr id="5" name="TextBox 4"/>
+      <p:pic>
+        <p:nvPicPr>
+          <p:cNvPr id="5" name="Picture 4" descr="slide15_swimlane.jpg"/>
+          <p:cNvPicPr>
+            <a:picLocks noChangeAspect="1"/>
+          </p:cNvPicPr>
+          <p:nvPr/>
+        </p:nvPicPr>
+        <p:blipFill>
+          <a:blip r:embed="rId2"/>
+          <a:stretch>
+            <a:fillRect/>
+          </a:stretch>
+        </p:blipFill>
+        <p:spPr>
+          <a:xfrm>
+            <a:off x="680392" y="1280160"/>
+            <a:ext cx="6685935" cy="4663440"/>
+          </a:xfrm>
+          <a:prstGeom prst="rect">
+            <a:avLst/>
+          </a:prstGeom>
+        </p:spPr>
+      </p:pic>
+      <p:sp>
+        <p:nvSpPr>
+          <p:cNvPr id="6" name="TextBox 5"/>
           <p:cNvSpPr txBox="1"/>
           <p:nvPr/>
         </p:nvSpPr>
         <p:spPr>
           <a:xfrm>
-            <a:off x="548640" y="1371600"/>
-            <a:ext cx="11094415" cy="4937760"/>
+            <a:off x="7863840" y="1417320"/>
+            <a:ext cx="3779215" cy="4663440"/>
           </a:xfrm>
           <a:prstGeom prst="rect">
             <a:avLst/>
@@ -9669,11 +9764,11 @@
           <a:p>
             <a:pPr>
               <a:spcAft>
-                <a:spcPts val="1200"/>
+                <a:spcPts val="1000"/>
               </a:spcAft>
             </a:pPr>
             <a:r>
-              <a:rPr sz="2200">
+              <a:rPr sz="1800">
                 <a:solidFill>
                   <a:srgbClr val="111111"/>
                 </a:solidFill>
@@ -9685,11 +9780,11 @@
           <a:p>
             <a:pPr>
               <a:spcAft>
-                <a:spcPts val="1200"/>
+                <a:spcPts val="1000"/>
               </a:spcAft>
             </a:pPr>
             <a:r>
-              <a:rPr sz="2200">
+              <a:rPr sz="1800">
                 <a:solidFill>
                   <a:srgbClr val="111111"/>
                 </a:solidFill>
@@ -9701,11 +9796,11 @@
           <a:p>
             <a:pPr>
               <a:spcAft>
-                <a:spcPts val="1200"/>
+                <a:spcPts val="1000"/>
               </a:spcAft>
             </a:pPr>
             <a:r>
-              <a:rPr sz="2200">
+              <a:rPr sz="1800">
                 <a:solidFill>
                   <a:srgbClr val="111111"/>
                 </a:solidFill>
@@ -9717,11 +9812,11 @@
           <a:p>
             <a:pPr>
               <a:spcAft>
-                <a:spcPts val="1200"/>
+                <a:spcPts val="1000"/>
               </a:spcAft>
             </a:pPr>
             <a:r>
-              <a:rPr sz="2200">
+              <a:rPr sz="1800">
                 <a:solidFill>
                   <a:srgbClr val="111111"/>
                 </a:solidFill>
@@ -9733,11 +9828,11 @@
           <a:p>
             <a:pPr>
               <a:spcAft>
-                <a:spcPts val="1200"/>
+                <a:spcPts val="1000"/>
               </a:spcAft>
             </a:pPr>
             <a:r>
-              <a:rPr sz="2200">
+              <a:rPr sz="1800">
                 <a:solidFill>
                   <a:srgbClr val="111111"/>
                 </a:solidFill>
@@ -9750,7 +9845,42 @@
       </p:sp>
       <p:sp>
         <p:nvSpPr>
-          <p:cNvPr id="6" name="Rectangle 5"/>
+          <p:cNvPr id="7" name="TextBox 6"/>
+          <p:cNvSpPr txBox="1"/>
+          <p:nvPr/>
+        </p:nvSpPr>
+        <p:spPr>
+          <a:xfrm>
+            <a:off x="4785055" y="6016752"/>
+            <a:ext cx="6858000" cy="274320"/>
+          </a:xfrm>
+          <a:prstGeom prst="rect">
+            <a:avLst/>
+          </a:prstGeom>
+          <a:noFill/>
+        </p:spPr>
+        <p:txBody>
+          <a:bodyPr wrap="square" anchor="t" lIns="45720" rIns="45720" tIns="27432" bIns="27432">
+            <a:spAutoFit/>
+          </a:bodyPr>
+          <a:lstStyle/>
+          <a:p>
+            <a:pPr algn="r"/>
+            <a:r>
+              <a:rPr sz="900" b="0" i="1">
+                <a:solidFill>
+                  <a:srgbClr val="666666"/>
+                </a:solidFill>
+                <a:latin typeface="Calibri"/>
+              </a:rPr>
+              <a:t>Diagram: Foundation for Public Code, Wikimedia Commons, CC0</a:t>
+            </a:r>
+          </a:p>
+        </p:txBody>
+      </p:sp>
+      <p:sp>
+        <p:nvSpPr>
+          <p:cNvPr id="8" name="Rectangle 7"/>
           <p:cNvSpPr/>
           <p:nvPr/>
         </p:nvSpPr>
@@ -9794,7 +9924,7 @@
       </p:sp>
       <p:sp>
         <p:nvSpPr>
-          <p:cNvPr id="7" name="TextBox 6"/>
+          <p:cNvPr id="9" name="TextBox 8"/>
           <p:cNvSpPr txBox="1"/>
           <p:nvPr/>
         </p:nvSpPr>
@@ -9829,7 +9959,7 @@
       </p:sp>
       <p:sp>
         <p:nvSpPr>
-          <p:cNvPr id="8" name="TextBox 7"/>
+          <p:cNvPr id="10" name="TextBox 9"/>
           <p:cNvSpPr txBox="1"/>
           <p:nvPr/>
         </p:nvSpPr>
@@ -10070,8 +10200,8 @@
         </p:nvSpPr>
         <p:spPr>
           <a:xfrm>
-            <a:off x="7071055" y="6016752"/>
-            <a:ext cx="4572000" cy="274320"/>
+            <a:off x="4785055" y="6016752"/>
+            <a:ext cx="6858000" cy="274320"/>
           </a:xfrm>
           <a:prstGeom prst="rect">
             <a:avLst/>
@@ -10753,8 +10883,8 @@
         </p:nvSpPr>
         <p:spPr>
           <a:xfrm>
-            <a:off x="7071055" y="6016752"/>
-            <a:ext cx="4572000" cy="274320"/>
+            <a:off x="4785055" y="6016752"/>
+            <a:ext cx="6858000" cy="274320"/>
           </a:xfrm>
           <a:prstGeom prst="rect">
             <a:avLst/>
@@ -10936,7 +11066,7 @@
           <a:p>
             <a:pPr algn="l"/>
             <a:r>
-              <a:rPr sz="3000" b="1" i="0">
+              <a:rPr sz="2600" b="1" i="0">
                 <a:solidFill>
                   <a:srgbClr val="111111"/>
                 </a:solidFill>
@@ -11035,95 +11165,40 @@
           </a:p>
         </p:txBody>
       </p:sp>
-      <p:sp>
-        <p:nvSpPr>
-          <p:cNvPr id="5" name="TextBox 4"/>
+      <p:pic>
+        <p:nvPicPr>
+          <p:cNvPr id="5" name="Picture 4" descr="slide19_queue.jpg"/>
+          <p:cNvPicPr>
+            <a:picLocks noChangeAspect="1"/>
+          </p:cNvPicPr>
+          <p:nvPr/>
+        </p:nvPicPr>
+        <p:blipFill>
+          <a:blip r:embed="rId2"/>
+          <a:stretch>
+            <a:fillRect/>
+          </a:stretch>
+        </p:blipFill>
+        <p:spPr>
+          <a:xfrm>
+            <a:off x="914400" y="1280160"/>
+            <a:ext cx="6217920" cy="4663440"/>
+          </a:xfrm>
+          <a:prstGeom prst="rect">
+            <a:avLst/>
+          </a:prstGeom>
+        </p:spPr>
+      </p:pic>
+      <p:sp>
+        <p:nvSpPr>
+          <p:cNvPr id="6" name="TextBox 5"/>
           <p:cNvSpPr txBox="1"/>
           <p:nvPr/>
         </p:nvSpPr>
         <p:spPr>
           <a:xfrm>
-            <a:off x="548640" y="1325880"/>
-            <a:ext cx="5318607" cy="457200"/>
-          </a:xfrm>
-          <a:prstGeom prst="rect">
-            <a:avLst/>
-          </a:prstGeom>
-          <a:noFill/>
-        </p:spPr>
-        <p:txBody>
-          <a:bodyPr wrap="square" anchor="t" lIns="45720" rIns="45720" tIns="27432" bIns="27432">
-            <a:spAutoFit/>
-          </a:bodyPr>
-          <a:lstStyle/>
-          <a:p>
-            <a:pPr algn="l"/>
-            <a:r>
-              <a:rPr sz="2000" b="1" i="0">
-                <a:solidFill>
-                  <a:srgbClr val="111111"/>
-                </a:solidFill>
-                <a:latin typeface="Calibri"/>
-              </a:rPr>
-              <a:t>Touch time</a:t>
-            </a:r>
-          </a:p>
-        </p:txBody>
-      </p:sp>
-      <p:sp>
-        <p:nvSpPr>
-          <p:cNvPr id="6" name="Rectangle 5"/>
-          <p:cNvSpPr/>
-          <p:nvPr/>
-        </p:nvSpPr>
-        <p:spPr>
-          <a:xfrm>
-            <a:off x="548640" y="1801368"/>
-            <a:ext cx="5318607" cy="25400"/>
-          </a:xfrm>
-          <a:prstGeom prst="rect">
-            <a:avLst/>
-          </a:prstGeom>
-          <a:solidFill>
-            <a:srgbClr val="F7A11A"/>
-          </a:solidFill>
-          <a:ln>
-            <a:noFill/>
-          </a:ln>
-          <a:effectLst/>
-        </p:spPr>
-        <p:style>
-          <a:lnRef idx="1">
-            <a:schemeClr val="accent1"/>
-          </a:lnRef>
-          <a:fillRef idx="3">
-            <a:schemeClr val="accent1"/>
-          </a:fillRef>
-          <a:effectRef idx="2">
-            <a:schemeClr val="accent1"/>
-          </a:effectRef>
-          <a:fontRef idx="minor">
-            <a:schemeClr val="lt1"/>
-          </a:fontRef>
-        </p:style>
-        <p:txBody>
-          <a:bodyPr rtlCol="0" anchor="ctr"/>
-          <a:lstStyle/>
-          <a:p>
-            <a:pPr algn="ctr"/>
-          </a:p>
-        </p:txBody>
-      </p:sp>
-      <p:sp>
-        <p:nvSpPr>
-          <p:cNvPr id="7" name="TextBox 6"/>
-          <p:cNvSpPr txBox="1"/>
-          <p:nvPr/>
-        </p:nvSpPr>
-        <p:spPr>
-          <a:xfrm>
-            <a:off x="548640" y="1920240"/>
-            <a:ext cx="5318607" cy="4297680"/>
+            <a:off x="7863840" y="1417320"/>
+            <a:ext cx="3779215" cy="4663440"/>
           </a:xfrm>
           <a:prstGeom prst="rect">
             <a:avLst/>
@@ -11148,7 +11223,7 @@
                 </a:solidFill>
                 <a:latin typeface="Calibri"/>
               </a:rPr>
-              <a:t>•  Minutes of actual work on the step</a:t>
+              <a:t>•  Touch time: minutes of actual work on the step, written inside the box</a:t>
             </a:r>
           </a:p>
           <a:p>
@@ -11164,7 +11239,7 @@
                 </a:solidFill>
                 <a:latin typeface="Calibri"/>
               </a:rPr>
-              <a:t>•  Written inside the box</a:t>
+              <a:t>•  Wait time: how long the work sits before the step starts, written on the arrow</a:t>
             </a:r>
           </a:p>
           <a:p>
@@ -11183,108 +11258,6 @@
               <a:t>•  Large touch time on reading or writing: fix with an AI step</a:t>
             </a:r>
           </a:p>
-        </p:txBody>
-      </p:sp>
-      <p:sp>
-        <p:nvSpPr>
-          <p:cNvPr id="8" name="TextBox 7"/>
-          <p:cNvSpPr txBox="1"/>
-          <p:nvPr/>
-        </p:nvSpPr>
-        <p:spPr>
-          <a:xfrm>
-            <a:off x="6324447" y="1325880"/>
-            <a:ext cx="5318607" cy="457200"/>
-          </a:xfrm>
-          <a:prstGeom prst="rect">
-            <a:avLst/>
-          </a:prstGeom>
-          <a:noFill/>
-        </p:spPr>
-        <p:txBody>
-          <a:bodyPr wrap="square" anchor="t" lIns="45720" rIns="45720" tIns="27432" bIns="27432">
-            <a:spAutoFit/>
-          </a:bodyPr>
-          <a:lstStyle/>
-          <a:p>
-            <a:pPr algn="l"/>
-            <a:r>
-              <a:rPr sz="2000" b="1" i="0">
-                <a:solidFill>
-                  <a:srgbClr val="111111"/>
-                </a:solidFill>
-                <a:latin typeface="Calibri"/>
-              </a:rPr>
-              <a:t>Wait time</a:t>
-            </a:r>
-          </a:p>
-        </p:txBody>
-      </p:sp>
-      <p:sp>
-        <p:nvSpPr>
-          <p:cNvPr id="9" name="Rectangle 8"/>
-          <p:cNvSpPr/>
-          <p:nvPr/>
-        </p:nvSpPr>
-        <p:spPr>
-          <a:xfrm>
-            <a:off x="6324447" y="1801368"/>
-            <a:ext cx="5318607" cy="25400"/>
-          </a:xfrm>
-          <a:prstGeom prst="rect">
-            <a:avLst/>
-          </a:prstGeom>
-          <a:solidFill>
-            <a:srgbClr val="666666"/>
-          </a:solidFill>
-          <a:ln>
-            <a:noFill/>
-          </a:ln>
-          <a:effectLst/>
-        </p:spPr>
-        <p:style>
-          <a:lnRef idx="1">
-            <a:schemeClr val="accent1"/>
-          </a:lnRef>
-          <a:fillRef idx="3">
-            <a:schemeClr val="accent1"/>
-          </a:fillRef>
-          <a:effectRef idx="2">
-            <a:schemeClr val="accent1"/>
-          </a:effectRef>
-          <a:fontRef idx="minor">
-            <a:schemeClr val="lt1"/>
-          </a:fontRef>
-        </p:style>
-        <p:txBody>
-          <a:bodyPr rtlCol="0" anchor="ctr"/>
-          <a:lstStyle/>
-          <a:p>
-            <a:pPr algn="ctr"/>
-          </a:p>
-        </p:txBody>
-      </p:sp>
-      <p:sp>
-        <p:nvSpPr>
-          <p:cNvPr id="10" name="TextBox 9"/>
-          <p:cNvSpPr txBox="1"/>
-          <p:nvPr/>
-        </p:nvSpPr>
-        <p:spPr>
-          <a:xfrm>
-            <a:off x="6324447" y="1920240"/>
-            <a:ext cx="5318607" cy="4297680"/>
-          </a:xfrm>
-          <a:prstGeom prst="rect">
-            <a:avLst/>
-          </a:prstGeom>
-          <a:noFill/>
-        </p:spPr>
-        <p:txBody>
-          <a:bodyPr wrap="square" lIns="45720" rIns="45720">
-            <a:spAutoFit/>
-          </a:bodyPr>
-          <a:lstStyle/>
           <a:p>
             <a:pPr>
               <a:spcAft>
@@ -11298,38 +11271,6 @@
                 </a:solidFill>
                 <a:latin typeface="Calibri"/>
               </a:rPr>
-              <a:t>•  How long the work sits before that step starts</a:t>
-            </a:r>
-          </a:p>
-          <a:p>
-            <a:pPr>
-              <a:spcAft>
-                <a:spcPts val="1000"/>
-              </a:spcAft>
-            </a:pPr>
-            <a:r>
-              <a:rPr sz="1800">
-                <a:solidFill>
-                  <a:srgbClr val="111111"/>
-                </a:solidFill>
-                <a:latin typeface="Calibri"/>
-              </a:rPr>
-              <a:t>•  Written on the arrow</a:t>
-            </a:r>
-          </a:p>
-          <a:p>
-            <a:pPr>
-              <a:spcAft>
-                <a:spcPts val="1000"/>
-              </a:spcAft>
-            </a:pPr>
-            <a:r>
-              <a:rPr sz="1800">
-                <a:solidFill>
-                  <a:srgbClr val="111111"/>
-                </a:solidFill>
-                <a:latin typeface="Calibri"/>
-              </a:rPr>
               <a:t>•  Large waits: fix with notifications, routing, reminders</a:t>
             </a:r>
           </a:p>
@@ -11337,7 +11278,42 @@
       </p:sp>
       <p:sp>
         <p:nvSpPr>
-          <p:cNvPr id="11" name="Rectangle 10"/>
+          <p:cNvPr id="7" name="TextBox 6"/>
+          <p:cNvSpPr txBox="1"/>
+          <p:nvPr/>
+        </p:nvSpPr>
+        <p:spPr>
+          <a:xfrm>
+            <a:off x="4785055" y="6016752"/>
+            <a:ext cx="6858000" cy="274320"/>
+          </a:xfrm>
+          <a:prstGeom prst="rect">
+            <a:avLst/>
+          </a:prstGeom>
+          <a:noFill/>
+        </p:spPr>
+        <p:txBody>
+          <a:bodyPr wrap="square" anchor="t" lIns="45720" rIns="45720" tIns="27432" bIns="27432">
+            <a:spAutoFit/>
+          </a:bodyPr>
+          <a:lstStyle/>
+          <a:p>
+            <a:pPr algn="r"/>
+            <a:r>
+              <a:rPr sz="900" b="0" i="1">
+                <a:solidFill>
+                  <a:srgbClr val="666666"/>
+                </a:solidFill>
+                <a:latin typeface="Calibri"/>
+              </a:rPr>
+              <a:t>Photo: B25es, Wikimedia Commons, CC BY-SA 4.0</a:t>
+            </a:r>
+          </a:p>
+        </p:txBody>
+      </p:sp>
+      <p:sp>
+        <p:nvSpPr>
+          <p:cNvPr id="8" name="Rectangle 7"/>
           <p:cNvSpPr/>
           <p:nvPr/>
         </p:nvSpPr>
@@ -11381,7 +11357,7 @@
       </p:sp>
       <p:sp>
         <p:nvSpPr>
-          <p:cNvPr id="12" name="TextBox 11"/>
+          <p:cNvPr id="9" name="TextBox 8"/>
           <p:cNvSpPr txBox="1"/>
           <p:nvPr/>
         </p:nvSpPr>
@@ -11416,7 +11392,7 @@
       </p:sp>
       <p:sp>
         <p:nvSpPr>
-          <p:cNvPr id="13" name="TextBox 12"/>
+          <p:cNvPr id="10" name="TextBox 9"/>
           <p:cNvSpPr txBox="1"/>
           <p:nvPr/>
         </p:nvSpPr>
@@ -12055,8 +12031,8 @@
         </p:nvSpPr>
         <p:spPr>
           <a:xfrm>
-            <a:off x="7071055" y="6016752"/>
-            <a:ext cx="4572000" cy="274320"/>
+            <a:off x="4785055" y="6016752"/>
+            <a:ext cx="6858000" cy="274320"/>
           </a:xfrm>
           <a:prstGeom prst="rect">
             <a:avLst/>
@@ -12238,7 +12214,7 @@
           <a:p>
             <a:pPr algn="l"/>
             <a:r>
-              <a:rPr sz="3000" b="1" i="0">
+              <a:rPr sz="2600" b="1" i="0">
                 <a:solidFill>
                   <a:srgbClr val="111111"/>
                 </a:solidFill>
@@ -12337,50 +12313,30 @@
           </a:p>
         </p:txBody>
       </p:sp>
-      <p:sp>
-        <p:nvSpPr>
-          <p:cNvPr id="5" name="Rectangle 4"/>
-          <p:cNvSpPr/>
-          <p:nvPr/>
-        </p:nvSpPr>
-        <p:spPr>
-          <a:xfrm>
-            <a:off x="548640" y="1783080"/>
-            <a:ext cx="76200" cy="2926080"/>
-          </a:xfrm>
-          <a:prstGeom prst="rect">
-            <a:avLst/>
-          </a:prstGeom>
-          <a:solidFill>
-            <a:srgbClr val="F7A11A"/>
-          </a:solidFill>
-          <a:ln>
-            <a:noFill/>
-          </a:ln>
-          <a:effectLst/>
-        </p:spPr>
-        <p:style>
-          <a:lnRef idx="1">
-            <a:schemeClr val="accent1"/>
-          </a:lnRef>
-          <a:fillRef idx="3">
-            <a:schemeClr val="accent1"/>
-          </a:fillRef>
-          <a:effectRef idx="2">
-            <a:schemeClr val="accent1"/>
-          </a:effectRef>
-          <a:fontRef idx="minor">
-            <a:schemeClr val="lt1"/>
-          </a:fontRef>
-        </p:style>
-        <p:txBody>
-          <a:bodyPr rtlCol="0" anchor="ctr"/>
-          <a:lstStyle/>
-          <a:p>
-            <a:pPr algn="ctr"/>
-          </a:p>
-        </p:txBody>
-      </p:sp>
+      <p:pic>
+        <p:nvPicPr>
+          <p:cNvPr id="5" name="Picture 4" descr="slide21_gemba.jpg"/>
+          <p:cNvPicPr>
+            <a:picLocks noChangeAspect="1"/>
+          </p:cNvPicPr>
+          <p:nvPr/>
+        </p:nvPicPr>
+        <p:blipFill>
+          <a:blip r:embed="rId2"/>
+          <a:stretch>
+            <a:fillRect/>
+          </a:stretch>
+        </p:blipFill>
+        <p:spPr>
+          <a:xfrm>
+            <a:off x="924729" y="1280160"/>
+            <a:ext cx="6197262" cy="4663440"/>
+          </a:xfrm>
+          <a:prstGeom prst="rect">
+            <a:avLst/>
+          </a:prstGeom>
+        </p:spPr>
+      </p:pic>
       <p:sp>
         <p:nvSpPr>
           <p:cNvPr id="6" name="TextBox 5"/>
@@ -12389,8 +12345,8 @@
         </p:nvSpPr>
         <p:spPr>
           <a:xfrm>
-            <a:off x="914400" y="1783080"/>
-            <a:ext cx="10728655" cy="2926080"/>
+            <a:off x="7863840" y="1417320"/>
+            <a:ext cx="3779215" cy="4663440"/>
           </a:xfrm>
           <a:prstGeom prst="rect">
             <a:avLst/>
@@ -12398,27 +12354,114 @@
           <a:noFill/>
         </p:spPr>
         <p:txBody>
-          <a:bodyPr wrap="square" anchor="ctr" lIns="45720" rIns="45720" tIns="27432" bIns="27432">
+          <a:bodyPr wrap="square" lIns="45720" rIns="45720">
             <a:spAutoFit/>
           </a:bodyPr>
           <a:lstStyle/>
           <a:p>
-            <a:pPr algn="l"/>
-            <a:r>
-              <a:rPr sz="2800" b="0" i="0">
+            <a:pPr>
+              <a:spcAft>
+                <a:spcPts val="1000"/>
+              </a:spcAft>
+            </a:pPr>
+            <a:r>
+              <a:rPr sz="1800">
                 <a:solidFill>
                   <a:srgbClr val="111111"/>
                 </a:solidFill>
                 <a:latin typeface="Calibri"/>
               </a:rPr>
-              <a:t>Include the workaround: the private team spreadsheet, the email to HR, the re-typing. That is the real process. The official procedure is fiction until someone follows it. Automate reality.</a:t>
-            </a:r>
-          </a:p>
-        </p:txBody>
-      </p:sp>
-      <p:sp>
-        <p:nvSpPr>
-          <p:cNvPr id="7" name="Rectangle 6"/>
+              <a:t>•  Go and see the work where it happens (in lean: the gemba)</a:t>
+            </a:r>
+          </a:p>
+          <a:p>
+            <a:pPr>
+              <a:spcAft>
+                <a:spcPts val="1000"/>
+              </a:spcAft>
+            </a:pPr>
+            <a:r>
+              <a:rPr sz="1800">
+                <a:solidFill>
+                  <a:srgbClr val="111111"/>
+                </a:solidFill>
+                <a:latin typeface="Calibri"/>
+              </a:rPr>
+              <a:t>•  Include the workaround: the private team spreadsheet, the email to HR, the re-typing</a:t>
+            </a:r>
+          </a:p>
+          <a:p>
+            <a:pPr>
+              <a:spcAft>
+                <a:spcPts val="1000"/>
+              </a:spcAft>
+            </a:pPr>
+            <a:r>
+              <a:rPr sz="1800">
+                <a:solidFill>
+                  <a:srgbClr val="111111"/>
+                </a:solidFill>
+                <a:latin typeface="Calibri"/>
+              </a:rPr>
+              <a:t>•  The official procedure is fiction until someone follows it</a:t>
+            </a:r>
+          </a:p>
+          <a:p>
+            <a:pPr>
+              <a:spcAft>
+                <a:spcPts val="1000"/>
+              </a:spcAft>
+            </a:pPr>
+            <a:r>
+              <a:rPr sz="1800">
+                <a:solidFill>
+                  <a:srgbClr val="111111"/>
+                </a:solidFill>
+                <a:latin typeface="Calibri"/>
+              </a:rPr>
+              <a:t>•  Automate reality</a:t>
+            </a:r>
+          </a:p>
+        </p:txBody>
+      </p:sp>
+      <p:sp>
+        <p:nvSpPr>
+          <p:cNvPr id="7" name="TextBox 6"/>
+          <p:cNvSpPr txBox="1"/>
+          <p:nvPr/>
+        </p:nvSpPr>
+        <p:spPr>
+          <a:xfrm>
+            <a:off x="4785055" y="6016752"/>
+            <a:ext cx="6858000" cy="274320"/>
+          </a:xfrm>
+          <a:prstGeom prst="rect">
+            <a:avLst/>
+          </a:prstGeom>
+          <a:noFill/>
+        </p:spPr>
+        <p:txBody>
+          <a:bodyPr wrap="square" anchor="t" lIns="45720" rIns="45720" tIns="27432" bIns="27432">
+            <a:spAutoFit/>
+          </a:bodyPr>
+          <a:lstStyle/>
+          <a:p>
+            <a:pPr algn="r"/>
+            <a:r>
+              <a:rPr sz="900" b="0" i="1">
+                <a:solidFill>
+                  <a:srgbClr val="666666"/>
+                </a:solidFill>
+                <a:latin typeface="Calibri"/>
+              </a:rPr>
+              <a:t>Photo: Anonyme, Wikimedia Commons, CC BY 2.5</a:t>
+            </a:r>
+          </a:p>
+        </p:txBody>
+      </p:sp>
+      <p:sp>
+        <p:nvSpPr>
+          <p:cNvPr id="8" name="Rectangle 7"/>
           <p:cNvSpPr/>
           <p:nvPr/>
         </p:nvSpPr>
@@ -12462,7 +12505,7 @@
       </p:sp>
       <p:sp>
         <p:nvSpPr>
-          <p:cNvPr id="8" name="TextBox 7"/>
+          <p:cNvPr id="9" name="TextBox 8"/>
           <p:cNvSpPr txBox="1"/>
           <p:nvPr/>
         </p:nvSpPr>
@@ -12497,7 +12540,7 @@
       </p:sp>
       <p:sp>
         <p:nvSpPr>
-          <p:cNvPr id="9" name="TextBox 8"/>
+          <p:cNvPr id="10" name="TextBox 9"/>
           <p:cNvSpPr txBox="1"/>
           <p:nvPr/>
         </p:nvSpPr>
@@ -13370,8 +13413,8 @@
         </p:nvSpPr>
         <p:spPr>
           <a:xfrm>
-            <a:off x="7071055" y="6016752"/>
-            <a:ext cx="4572000" cy="274320"/>
+            <a:off x="4785055" y="6016752"/>
+            <a:ext cx="6858000" cy="274320"/>
           </a:xfrm>
           <a:prstGeom prst="rect">
             <a:avLst/>
@@ -13719,8 +13762,8 @@
         </p:nvSpPr>
         <p:spPr>
           <a:xfrm>
-            <a:off x="7071055" y="6016752"/>
-            <a:ext cx="4572000" cy="274320"/>
+            <a:off x="4785055" y="6016752"/>
+            <a:ext cx="6858000" cy="274320"/>
           </a:xfrm>
           <a:prstGeom prst="rect">
             <a:avLst/>
@@ -13902,7 +13945,7 @@
           <a:p>
             <a:pPr algn="l"/>
             <a:r>
-              <a:rPr sz="3000" b="1" i="0">
+              <a:rPr sz="2600" b="1" i="0">
                 <a:solidFill>
                   <a:srgbClr val="111111"/>
                 </a:solidFill>
@@ -14001,50 +14044,30 @@
           </a:p>
         </p:txBody>
       </p:sp>
-      <p:sp>
-        <p:nvSpPr>
-          <p:cNvPr id="5" name="Rectangle 4"/>
-          <p:cNvSpPr/>
-          <p:nvPr/>
-        </p:nvSpPr>
-        <p:spPr>
-          <a:xfrm>
-            <a:off x="548640" y="1783080"/>
-            <a:ext cx="76200" cy="2926080"/>
-          </a:xfrm>
-          <a:prstGeom prst="rect">
-            <a:avLst/>
-          </a:prstGeom>
-          <a:solidFill>
-            <a:srgbClr val="F7A11A"/>
-          </a:solidFill>
-          <a:ln>
-            <a:noFill/>
-          </a:ln>
-          <a:effectLst/>
-        </p:spPr>
-        <p:style>
-          <a:lnRef idx="1">
-            <a:schemeClr val="accent1"/>
-          </a:lnRef>
-          <a:fillRef idx="3">
-            <a:schemeClr val="accent1"/>
-          </a:fillRef>
-          <a:effectRef idx="2">
-            <a:schemeClr val="accent1"/>
-          </a:effectRef>
-          <a:fontRef idx="minor">
-            <a:schemeClr val="lt1"/>
-          </a:fontRef>
-        </p:style>
-        <p:txBody>
-          <a:bodyPr rtlCol="0" anchor="ctr"/>
-          <a:lstStyle/>
-          <a:p>
-            <a:pPr algn="ctr"/>
-          </a:p>
-        </p:txBody>
-      </p:sp>
+      <p:pic>
+        <p:nvPicPr>
+          <p:cNvPr id="5" name="Picture 4" descr="slide26_judgement.jpg"/>
+          <p:cNvPicPr>
+            <a:picLocks noChangeAspect="1"/>
+          </p:cNvPicPr>
+          <p:nvPr/>
+        </p:nvPicPr>
+        <p:blipFill>
+          <a:blip r:embed="rId2"/>
+          <a:stretch>
+            <a:fillRect/>
+          </a:stretch>
+        </p:blipFill>
+        <p:spPr>
+          <a:xfrm>
+            <a:off x="914400" y="1280160"/>
+            <a:ext cx="6217920" cy="4663440"/>
+          </a:xfrm>
+          <a:prstGeom prst="rect">
+            <a:avLst/>
+          </a:prstGeom>
+        </p:spPr>
+      </p:pic>
       <p:sp>
         <p:nvSpPr>
           <p:cNvPr id="6" name="TextBox 5"/>
@@ -14053,8 +14076,8 @@
         </p:nvSpPr>
         <p:spPr>
           <a:xfrm>
-            <a:off x="914400" y="1783080"/>
-            <a:ext cx="10728655" cy="2926080"/>
+            <a:off x="7863840" y="1417320"/>
+            <a:ext cx="3779215" cy="4663440"/>
           </a:xfrm>
           <a:prstGeom prst="rect">
             <a:avLst/>
@@ -14062,27 +14085,98 @@
           <a:noFill/>
         </p:spPr>
         <p:txBody>
-          <a:bodyPr wrap="square" anchor="ctr" lIns="45720" rIns="45720" tIns="27432" bIns="27432">
+          <a:bodyPr wrap="square" lIns="45720" rIns="45720">
             <a:spAutoFit/>
           </a:bodyPr>
           <a:lstStyle/>
           <a:p>
-            <a:pPr algn="l"/>
-            <a:r>
-              <a:rPr sz="2800" b="0" i="0">
+            <a:pPr>
+              <a:spcAft>
+                <a:spcPts val="1000"/>
+              </a:spcAft>
+            </a:pPr>
+            <a:r>
+              <a:rPr sz="1800">
                 <a:solidFill>
                   <a:srgbClr val="111111"/>
                 </a:solidFill>
                 <a:latin typeface="Calibri"/>
               </a:rPr>
-              <a:t>A JUDGE step is a real decision that needs a person's judgement or accountability. Do not automate it. Protect it, and give the person a better summary. Marking it now is how the human stays in the loop by design, not by accident (Day 5, Module 10).</a:t>
-            </a:r>
-          </a:p>
-        </p:txBody>
-      </p:sp>
-      <p:sp>
-        <p:nvSpPr>
-          <p:cNvPr id="7" name="Rectangle 6"/>
+              <a:t>•  A JUDGE step is a real decision that needs a person's judgement or accountability</a:t>
+            </a:r>
+          </a:p>
+          <a:p>
+            <a:pPr>
+              <a:spcAft>
+                <a:spcPts val="1000"/>
+              </a:spcAft>
+            </a:pPr>
+            <a:r>
+              <a:rPr sz="1800">
+                <a:solidFill>
+                  <a:srgbClr val="111111"/>
+                </a:solidFill>
+                <a:latin typeface="Calibri"/>
+              </a:rPr>
+              <a:t>•  Do not automate it. Protect it, and give the person a better summary</a:t>
+            </a:r>
+          </a:p>
+          <a:p>
+            <a:pPr>
+              <a:spcAft>
+                <a:spcPts val="1000"/>
+              </a:spcAft>
+            </a:pPr>
+            <a:r>
+              <a:rPr sz="1800">
+                <a:solidFill>
+                  <a:srgbClr val="111111"/>
+                </a:solidFill>
+                <a:latin typeface="Calibri"/>
+              </a:rPr>
+              <a:t>•  Marking it now keeps the human in the loop by design, not by accident (Day 5, Module 10)</a:t>
+            </a:r>
+          </a:p>
+        </p:txBody>
+      </p:sp>
+      <p:sp>
+        <p:nvSpPr>
+          <p:cNvPr id="7" name="TextBox 6"/>
+          <p:cNvSpPr txBox="1"/>
+          <p:nvPr/>
+        </p:nvSpPr>
+        <p:spPr>
+          <a:xfrm>
+            <a:off x="4785055" y="6016752"/>
+            <a:ext cx="6858000" cy="274320"/>
+          </a:xfrm>
+          <a:prstGeom prst="rect">
+            <a:avLst/>
+          </a:prstGeom>
+          <a:noFill/>
+        </p:spPr>
+        <p:txBody>
+          <a:bodyPr wrap="square" anchor="t" lIns="45720" rIns="45720" tIns="27432" bIns="27432">
+            <a:spAutoFit/>
+          </a:bodyPr>
+          <a:lstStyle/>
+          <a:p>
+            <a:pPr algn="r"/>
+            <a:r>
+              <a:rPr sz="900" b="0" i="1">
+                <a:solidFill>
+                  <a:srgbClr val="666666"/>
+                </a:solidFill>
+                <a:latin typeface="Calibri"/>
+              </a:rPr>
+              <a:t>Photo: Blogtrepreneur, Wikimedia Commons, CC BY 2.0</a:t>
+            </a:r>
+          </a:p>
+        </p:txBody>
+      </p:sp>
+      <p:sp>
+        <p:nvSpPr>
+          <p:cNvPr id="8" name="Rectangle 7"/>
           <p:cNvSpPr/>
           <p:nvPr/>
         </p:nvSpPr>
@@ -14126,7 +14220,7 @@
       </p:sp>
       <p:sp>
         <p:nvSpPr>
-          <p:cNvPr id="8" name="TextBox 7"/>
+          <p:cNvPr id="9" name="TextBox 8"/>
           <p:cNvSpPr txBox="1"/>
           <p:nvPr/>
         </p:nvSpPr>
@@ -14161,7 +14255,7 @@
       </p:sp>
       <p:sp>
         <p:nvSpPr>
-          <p:cNvPr id="9" name="TextBox 8"/>
+          <p:cNvPr id="10" name="TextBox 9"/>
           <p:cNvSpPr txBox="1"/>
           <p:nvPr/>
         </p:nvSpPr>
@@ -16265,7 +16359,7 @@
           <a:p>
             <a:pPr algn="l"/>
             <a:r>
-              <a:rPr sz="3000" b="1" i="0">
+              <a:rPr sz="2600" b="1" i="0">
                 <a:solidFill>
                   <a:srgbClr val="111111"/>
                 </a:solidFill>
@@ -16364,16 +16458,40 @@
           </a:p>
         </p:txBody>
       </p:sp>
-      <p:sp>
-        <p:nvSpPr>
-          <p:cNvPr id="5" name="TextBox 4"/>
+      <p:pic>
+        <p:nvPicPr>
+          <p:cNvPr id="5" name="Picture 4" descr="slide28_interview.jpg"/>
+          <p:cNvPicPr>
+            <a:picLocks noChangeAspect="1"/>
+          </p:cNvPicPr>
+          <p:nvPr/>
+        </p:nvPicPr>
+        <p:blipFill>
+          <a:blip r:embed="rId2"/>
+          <a:stretch>
+            <a:fillRect/>
+          </a:stretch>
+        </p:blipFill>
+        <p:spPr>
+          <a:xfrm>
+            <a:off x="548640" y="1357655"/>
+            <a:ext cx="6949439" cy="4508449"/>
+          </a:xfrm>
+          <a:prstGeom prst="rect">
+            <a:avLst/>
+          </a:prstGeom>
+        </p:spPr>
+      </p:pic>
+      <p:sp>
+        <p:nvSpPr>
+          <p:cNvPr id="6" name="TextBox 5"/>
           <p:cNvSpPr txBox="1"/>
           <p:nvPr/>
         </p:nvSpPr>
         <p:spPr>
           <a:xfrm>
-            <a:off x="548640" y="1371600"/>
-            <a:ext cx="11094415" cy="4937760"/>
+            <a:off x="7863840" y="1417320"/>
+            <a:ext cx="3779215" cy="4663440"/>
           </a:xfrm>
           <a:prstGeom prst="rect">
             <a:avLst/>
@@ -16388,11 +16506,11 @@
           <a:p>
             <a:pPr>
               <a:spcAft>
-                <a:spcPts val="1200"/>
+                <a:spcPts val="1000"/>
               </a:spcAft>
             </a:pPr>
             <a:r>
-              <a:rPr sz="2200">
+              <a:rPr sz="1700">
                 <a:solidFill>
                   <a:srgbClr val="111111"/>
                 </a:solidFill>
@@ -16404,11 +16522,11 @@
           <a:p>
             <a:pPr>
               <a:spcAft>
-                <a:spcPts val="1200"/>
+                <a:spcPts val="1000"/>
               </a:spcAft>
             </a:pPr>
             <a:r>
-              <a:rPr sz="2200">
+              <a:rPr sz="1700">
                 <a:solidFill>
                   <a:srgbClr val="111111"/>
                 </a:solidFill>
@@ -16420,11 +16538,11 @@
           <a:p>
             <a:pPr>
               <a:spcAft>
-                <a:spcPts val="1200"/>
+                <a:spcPts val="1000"/>
               </a:spcAft>
             </a:pPr>
             <a:r>
-              <a:rPr sz="2200">
+              <a:rPr sz="1700">
                 <a:solidFill>
                   <a:srgbClr val="111111"/>
                 </a:solidFill>
@@ -16436,11 +16554,11 @@
           <a:p>
             <a:pPr>
               <a:spcAft>
-                <a:spcPts val="1200"/>
+                <a:spcPts val="1000"/>
               </a:spcAft>
             </a:pPr>
             <a:r>
-              <a:rPr sz="2200">
+              <a:rPr sz="1700">
                 <a:solidFill>
                   <a:srgbClr val="111111"/>
                 </a:solidFill>
@@ -16452,11 +16570,11 @@
           <a:p>
             <a:pPr>
               <a:spcAft>
-                <a:spcPts val="1200"/>
+                <a:spcPts val="1000"/>
               </a:spcAft>
             </a:pPr>
             <a:r>
-              <a:rPr sz="2200">
+              <a:rPr sz="1700">
                 <a:solidFill>
                   <a:srgbClr val="111111"/>
                 </a:solidFill>
@@ -16469,7 +16587,42 @@
       </p:sp>
       <p:sp>
         <p:nvSpPr>
-          <p:cNvPr id="6" name="Rectangle 5"/>
+          <p:cNvPr id="7" name="TextBox 6"/>
+          <p:cNvSpPr txBox="1"/>
+          <p:nvPr/>
+        </p:nvSpPr>
+        <p:spPr>
+          <a:xfrm>
+            <a:off x="4785055" y="6016752"/>
+            <a:ext cx="6858000" cy="274320"/>
+          </a:xfrm>
+          <a:prstGeom prst="rect">
+            <a:avLst/>
+          </a:prstGeom>
+          <a:noFill/>
+        </p:spPr>
+        <p:txBody>
+          <a:bodyPr wrap="square" anchor="t" lIns="45720" rIns="45720" tIns="27432" bIns="27432">
+            <a:spAutoFit/>
+          </a:bodyPr>
+          <a:lstStyle/>
+          <a:p>
+            <a:pPr algn="r"/>
+            <a:r>
+              <a:rPr sz="900" b="0" i="1">
+                <a:solidFill>
+                  <a:srgbClr val="666666"/>
+                </a:solidFill>
+                <a:latin typeface="Calibri"/>
+              </a:rPr>
+              <a:t>Photo: amtec_photos, Wikimedia Commons, CC BY-SA 2.0</a:t>
+            </a:r>
+          </a:p>
+        </p:txBody>
+      </p:sp>
+      <p:sp>
+        <p:nvSpPr>
+          <p:cNvPr id="8" name="Rectangle 7"/>
           <p:cNvSpPr/>
           <p:nvPr/>
         </p:nvSpPr>
@@ -16513,7 +16666,7 @@
       </p:sp>
       <p:sp>
         <p:nvSpPr>
-          <p:cNvPr id="7" name="TextBox 6"/>
+          <p:cNvPr id="9" name="TextBox 8"/>
           <p:cNvSpPr txBox="1"/>
           <p:nvPr/>
         </p:nvSpPr>
@@ -16548,7 +16701,7 @@
       </p:sp>
       <p:sp>
         <p:nvSpPr>
-          <p:cNvPr id="8" name="TextBox 7"/>
+          <p:cNvPr id="10" name="TextBox 9"/>
           <p:cNvSpPr txBox="1"/>
           <p:nvPr/>
         </p:nvSpPr>
@@ -24895,6 +25048,396 @@
 </p:sld>
 </file>
 
+<file path=ppt/slides/slide46.xml><?xml version="1.0" encoding="utf-8"?>
+<p:sld xmlns:a="http://schemas.openxmlformats.org/drawingml/2006/main" xmlns:p="http://schemas.openxmlformats.org/presentationml/2006/main" xmlns:r="http://schemas.openxmlformats.org/officeDocument/2006/relationships">
+  <p:cSld>
+    <p:spTree>
+      <p:nvGrpSpPr>
+        <p:cNvPr id="1" name=""/>
+        <p:cNvGrpSpPr/>
+        <p:nvPr/>
+      </p:nvGrpSpPr>
+      <p:grpSpPr/>
+      <p:sp>
+        <p:nvSpPr>
+          <p:cNvPr id="2" name="TextBox 1"/>
+          <p:cNvSpPr txBox="1"/>
+          <p:nvPr/>
+        </p:nvSpPr>
+        <p:spPr>
+          <a:xfrm>
+            <a:off x="548640" y="365760"/>
+            <a:ext cx="11094415" cy="777240"/>
+          </a:xfrm>
+          <a:prstGeom prst="rect">
+            <a:avLst/>
+          </a:prstGeom>
+          <a:noFill/>
+        </p:spPr>
+        <p:txBody>
+          <a:bodyPr wrap="square" anchor="b" lIns="45720" rIns="45720" tIns="27432" bIns="27432">
+            <a:spAutoFit/>
+          </a:bodyPr>
+          <a:lstStyle/>
+          <a:p>
+            <a:pPr algn="l"/>
+            <a:r>
+              <a:rPr sz="3000" b="1" i="0">
+                <a:solidFill>
+                  <a:srgbClr val="111111"/>
+                </a:solidFill>
+                <a:latin typeface="Calibri"/>
+              </a:rPr>
+              <a:t>Image credits</a:t>
+            </a:r>
+          </a:p>
+        </p:txBody>
+      </p:sp>
+      <p:sp>
+        <p:nvSpPr>
+          <p:cNvPr id="3" name="Rectangle 2"/>
+          <p:cNvSpPr/>
+          <p:nvPr/>
+        </p:nvSpPr>
+        <p:spPr>
+          <a:xfrm>
+            <a:off x="548640" y="1115568"/>
+            <a:ext cx="1097280" cy="38100"/>
+          </a:xfrm>
+          <a:prstGeom prst="rect">
+            <a:avLst/>
+          </a:prstGeom>
+          <a:solidFill>
+            <a:srgbClr val="F7A11A"/>
+          </a:solidFill>
+          <a:ln>
+            <a:noFill/>
+          </a:ln>
+          <a:effectLst/>
+        </p:spPr>
+        <p:style>
+          <a:lnRef idx="1">
+            <a:schemeClr val="accent1"/>
+          </a:lnRef>
+          <a:fillRef idx="3">
+            <a:schemeClr val="accent1"/>
+          </a:fillRef>
+          <a:effectRef idx="2">
+            <a:schemeClr val="accent1"/>
+          </a:effectRef>
+          <a:fontRef idx="minor">
+            <a:schemeClr val="lt1"/>
+          </a:fontRef>
+        </p:style>
+        <p:txBody>
+          <a:bodyPr rtlCol="0" anchor="ctr"/>
+          <a:lstStyle/>
+          <a:p>
+            <a:pPr algn="ctr"/>
+          </a:p>
+        </p:txBody>
+      </p:sp>
+      <p:sp>
+        <p:nvSpPr>
+          <p:cNvPr id="4" name="Rectangle 3"/>
+          <p:cNvSpPr/>
+          <p:nvPr/>
+        </p:nvSpPr>
+        <p:spPr>
+          <a:xfrm>
+            <a:off x="1645920" y="1115568"/>
+            <a:ext cx="9997135" cy="19050"/>
+          </a:xfrm>
+          <a:prstGeom prst="rect">
+            <a:avLst/>
+          </a:prstGeom>
+          <a:solidFill>
+            <a:srgbClr val="DDDDDD"/>
+          </a:solidFill>
+          <a:ln>
+            <a:noFill/>
+          </a:ln>
+          <a:effectLst/>
+        </p:spPr>
+        <p:style>
+          <a:lnRef idx="1">
+            <a:schemeClr val="accent1"/>
+          </a:lnRef>
+          <a:fillRef idx="3">
+            <a:schemeClr val="accent1"/>
+          </a:fillRef>
+          <a:effectRef idx="2">
+            <a:schemeClr val="accent1"/>
+          </a:effectRef>
+          <a:fontRef idx="minor">
+            <a:schemeClr val="lt1"/>
+          </a:fontRef>
+        </p:style>
+        <p:txBody>
+          <a:bodyPr rtlCol="0" anchor="ctr"/>
+          <a:lstStyle/>
+          <a:p>
+            <a:pPr algn="ctr"/>
+          </a:p>
+        </p:txBody>
+      </p:sp>
+      <p:sp>
+        <p:nvSpPr>
+          <p:cNvPr id="5" name="TextBox 4"/>
+          <p:cNvSpPr txBox="1"/>
+          <p:nvPr/>
+        </p:nvSpPr>
+        <p:spPr>
+          <a:xfrm>
+            <a:off x="548640" y="1371600"/>
+            <a:ext cx="11094415" cy="4663440"/>
+          </a:xfrm>
+          <a:prstGeom prst="rect">
+            <a:avLst/>
+          </a:prstGeom>
+          <a:noFill/>
+        </p:spPr>
+        <p:txBody>
+          <a:bodyPr wrap="square" lIns="45720" rIns="45720">
+            <a:spAutoFit/>
+          </a:bodyPr>
+          <a:lstStyle/>
+          <a:p>
+            <a:pPr>
+              <a:spcAft>
+                <a:spcPts val="600"/>
+              </a:spcAft>
+            </a:pPr>
+            <a:r>
+              <a:rPr sz="1400">
+                <a:solidFill>
+                  <a:srgbClr val="111111"/>
+                </a:solidFill>
+                <a:latin typeface="Calibri"/>
+              </a:rPr>
+              <a:t>1.  KUKA Industrial Robots IR.jpg: Mixabest, CC BY-SA 3.0 (creativecommons.org/licenses/by-sa/3.0). commons.wikimedia.org/wiki/File:KUKA_Industrial_Robots_IR.jpg</a:t>
+            </a:r>
+          </a:p>
+          <a:p>
+            <a:pPr>
+              <a:spcAft>
+                <a:spcPts val="600"/>
+              </a:spcAft>
+            </a:pPr>
+            <a:r>
+              <a:rPr sz="1400">
+                <a:solidFill>
+                  <a:srgbClr val="111111"/>
+                </a:solidFill>
+                <a:latin typeface="Calibri"/>
+              </a:rPr>
+              <a:t>2.  Value Stream Mapping map 015.jpg: Adrian Grycuk, CC BY-SA 3.0 PL (creativecommons.org/licenses/by-sa/3.0/pl/deed.en). commons.wikimedia.org/wiki/File:Value_Stream_Mapping_map_015.jpg</a:t>
+            </a:r>
+          </a:p>
+          <a:p>
+            <a:pPr>
+              <a:spcAft>
+                <a:spcPts val="600"/>
+              </a:spcAft>
+            </a:pPr>
+            <a:r>
+              <a:rPr sz="1400">
+                <a:solidFill>
+                  <a:srgbClr val="111111"/>
+                </a:solidFill>
+                <a:latin typeface="Calibri"/>
+              </a:rPr>
+              <a:t>3.  Audit-flow.svg: Foundation for Public Code, CC0 (creativecommons.org/publicdomain/zero/1.0/deed.en). commons.wikimedia.org/wiki/File:Audit-flow.svg</a:t>
+            </a:r>
+          </a:p>
+          <a:p>
+            <a:pPr>
+              <a:spcAft>
+                <a:spcPts val="600"/>
+              </a:spcAft>
+            </a:pPr>
+            <a:r>
+              <a:rPr sz="1400">
+                <a:solidFill>
+                  <a:srgbClr val="111111"/>
+                </a:solidFill>
+                <a:latin typeface="Calibri"/>
+              </a:rPr>
+              <a:t>4.  Bandejas de correo.jpg: B25es, CC BY-SA 4.0 (creativecommons.org/licenses/by-sa/4.0). commons.wikimedia.org/wiki/File:Bandejas_de_correo.jpg</a:t>
+            </a:r>
+          </a:p>
+          <a:p>
+            <a:pPr>
+              <a:spcAft>
+                <a:spcPts val="600"/>
+              </a:spcAft>
+            </a:pPr>
+            <a:r>
+              <a:rPr sz="1400">
+                <a:solidFill>
+                  <a:srgbClr val="111111"/>
+                </a:solidFill>
+                <a:latin typeface="Calibri"/>
+              </a:rPr>
+              <a:t>5.  Hyundai car assembly line.jpg: Anonyme (Wikimedia Commons user), CC BY 2.5 (creativecommons.org/licenses/by/2.5). commons.wikimedia.org/wiki/File:Hyundai_car_assembly_line.jpg</a:t>
+            </a:r>
+          </a:p>
+          <a:p>
+            <a:pPr>
+              <a:spcAft>
+                <a:spcPts val="600"/>
+              </a:spcAft>
+            </a:pPr>
+            <a:r>
+              <a:rPr sz="1400">
+                <a:solidFill>
+                  <a:srgbClr val="111111"/>
+                </a:solidFill>
+                <a:latin typeface="Calibri"/>
+              </a:rPr>
+              <a:t>6.  Legal Contract &amp; Signature - Warm Tones.jpg: Blogtrepreneur, CC BY 2.0 (creativecommons.org/licenses/by/2.0). commons.wikimedia.org/wiki/File:Legal_Contract_%26_Signature_-_Warm_Tones.jpg</a:t>
+            </a:r>
+          </a:p>
+          <a:p>
+            <a:pPr>
+              <a:spcAft>
+                <a:spcPts val="600"/>
+              </a:spcAft>
+            </a:pPr>
+            <a:r>
+              <a:rPr sz="1400">
+                <a:solidFill>
+                  <a:srgbClr val="111111"/>
+                </a:solidFill>
+                <a:latin typeface="Calibri"/>
+              </a:rPr>
+              <a:t>7.  Job Interview - 38630953066.jpg: amtec_photos (Amtec Photos, https://www.amtec.us.com), CC BY-SA 2.0 (creativecommons.org/licenses/by-sa/2.0). commons.wikimedia.org/wiki/File:Job_Interview_-_38630953066.jpg</a:t>
+            </a:r>
+          </a:p>
+        </p:txBody>
+      </p:sp>
+      <p:sp>
+        <p:nvSpPr>
+          <p:cNvPr id="6" name="Rectangle 5"/>
+          <p:cNvSpPr/>
+          <p:nvPr/>
+        </p:nvSpPr>
+        <p:spPr>
+          <a:xfrm>
+            <a:off x="548640" y="6309360"/>
+            <a:ext cx="11094415" cy="19050"/>
+          </a:xfrm>
+          <a:prstGeom prst="rect">
+            <a:avLst/>
+          </a:prstGeom>
+          <a:solidFill>
+            <a:srgbClr val="DDDDDD"/>
+          </a:solidFill>
+          <a:ln>
+            <a:noFill/>
+          </a:ln>
+          <a:effectLst/>
+        </p:spPr>
+        <p:style>
+          <a:lnRef idx="1">
+            <a:schemeClr val="accent1"/>
+          </a:lnRef>
+          <a:fillRef idx="3">
+            <a:schemeClr val="accent1"/>
+          </a:fillRef>
+          <a:effectRef idx="2">
+            <a:schemeClr val="accent1"/>
+          </a:effectRef>
+          <a:fontRef idx="minor">
+            <a:schemeClr val="lt1"/>
+          </a:fontRef>
+        </p:style>
+        <p:txBody>
+          <a:bodyPr rtlCol="0" anchor="ctr"/>
+          <a:lstStyle/>
+          <a:p>
+            <a:pPr algn="ctr"/>
+          </a:p>
+        </p:txBody>
+      </p:sp>
+      <p:sp>
+        <p:nvSpPr>
+          <p:cNvPr id="7" name="TextBox 6"/>
+          <p:cNvSpPr txBox="1"/>
+          <p:nvPr/>
+        </p:nvSpPr>
+        <p:spPr>
+          <a:xfrm>
+            <a:off x="548640" y="6355080"/>
+            <a:ext cx="9144000" cy="365760"/>
+          </a:xfrm>
+          <a:prstGeom prst="rect">
+            <a:avLst/>
+          </a:prstGeom>
+          <a:noFill/>
+        </p:spPr>
+        <p:txBody>
+          <a:bodyPr wrap="square" anchor="t" lIns="45720" rIns="45720" tIns="27432" bIns="27432">
+            <a:spAutoFit/>
+          </a:bodyPr>
+          <a:lstStyle/>
+          <a:p>
+            <a:pPr algn="l"/>
+            <a:r>
+              <a:rPr sz="1000" b="0" i="0">
+                <a:solidFill>
+                  <a:srgbClr val="666666"/>
+                </a:solidFill>
+                <a:latin typeface="Calibri"/>
+              </a:rPr>
+              <a:t>IEEE CS Region 8 AI Caravan 2026 · AI Administrator · Day 2 · Session 3</a:t>
+            </a:r>
+          </a:p>
+        </p:txBody>
+      </p:sp>
+      <p:sp>
+        <p:nvSpPr>
+          <p:cNvPr id="8" name="TextBox 7"/>
+          <p:cNvSpPr txBox="1"/>
+          <p:nvPr/>
+        </p:nvSpPr>
+        <p:spPr>
+          <a:xfrm>
+            <a:off x="10271455" y="6355080"/>
+            <a:ext cx="1371600" cy="365760"/>
+          </a:xfrm>
+          <a:prstGeom prst="rect">
+            <a:avLst/>
+          </a:prstGeom>
+          <a:noFill/>
+        </p:spPr>
+        <p:txBody>
+          <a:bodyPr wrap="square" anchor="t" lIns="45720" rIns="45720" tIns="27432" bIns="27432">
+            <a:spAutoFit/>
+          </a:bodyPr>
+          <a:lstStyle/>
+          <a:p>
+            <a:pPr algn="r"/>
+            <a:r>
+              <a:rPr sz="1000" b="0" i="0">
+                <a:solidFill>
+                  <a:srgbClr val="666666"/>
+                </a:solidFill>
+                <a:latin typeface="Calibri"/>
+              </a:rPr>
+              <a:t>46</a:t>
+            </a:r>
+          </a:p>
+        </p:txBody>
+      </p:sp>
+    </p:spTree>
+  </p:cSld>
+  <p:clrMapOvr>
+    <a:masterClrMapping/>
+  </p:clrMapOvr>
+</p:sld>
+</file>
+
 <file path=ppt/slides/slide5.xml><?xml version="1.0" encoding="utf-8"?>
 <p:sld xmlns:a="http://schemas.openxmlformats.org/drawingml/2006/main" xmlns:p="http://schemas.openxmlformats.org/presentationml/2006/main" xmlns:r="http://schemas.openxmlformats.org/officeDocument/2006/relationships">
   <p:cSld>
@@ -25245,7 +25788,7 @@
           <a:p>
             <a:pPr algn="l"/>
             <a:r>
-              <a:rPr sz="3000" b="1" i="0">
+              <a:rPr sz="2600" b="1" i="0">
                 <a:solidFill>
                   <a:srgbClr val="111111"/>
                 </a:solidFill>
@@ -25344,50 +25887,30 @@
           </a:p>
         </p:txBody>
       </p:sp>
-      <p:sp>
-        <p:nvSpPr>
-          <p:cNvPr id="5" name="Rectangle 4"/>
-          <p:cNvSpPr/>
-          <p:nvPr/>
-        </p:nvSpPr>
-        <p:spPr>
-          <a:xfrm>
-            <a:off x="548640" y="1783080"/>
-            <a:ext cx="76200" cy="2926080"/>
-          </a:xfrm>
-          <a:prstGeom prst="rect">
-            <a:avLst/>
-          </a:prstGeom>
-          <a:solidFill>
-            <a:srgbClr val="F7A11A"/>
-          </a:solidFill>
-          <a:ln>
-            <a:noFill/>
-          </a:ln>
-          <a:effectLst/>
-        </p:spPr>
-        <p:style>
-          <a:lnRef idx="1">
-            <a:schemeClr val="accent1"/>
-          </a:lnRef>
-          <a:fillRef idx="3">
-            <a:schemeClr val="accent1"/>
-          </a:fillRef>
-          <a:effectRef idx="2">
-            <a:schemeClr val="accent1"/>
-          </a:effectRef>
-          <a:fontRef idx="minor">
-            <a:schemeClr val="lt1"/>
-          </a:fontRef>
-        </p:style>
-        <p:txBody>
-          <a:bodyPr rtlCol="0" anchor="ctr"/>
-          <a:lstStyle/>
-          <a:p>
-            <a:pPr algn="ctr"/>
-          </a:p>
-        </p:txBody>
-      </p:sp>
+      <p:pic>
+        <p:nvPicPr>
+          <p:cNvPr id="5" name="Picture 4" descr="slide6_automation.jpg"/>
+          <p:cNvPicPr>
+            <a:picLocks noChangeAspect="1"/>
+          </p:cNvPicPr>
+          <p:nvPr/>
+        </p:nvPicPr>
+        <p:blipFill>
+          <a:blip r:embed="rId2"/>
+          <a:stretch>
+            <a:fillRect/>
+          </a:stretch>
+        </p:blipFill>
+        <p:spPr>
+          <a:xfrm>
+            <a:off x="548640" y="1301610"/>
+            <a:ext cx="6949440" cy="4620539"/>
+          </a:xfrm>
+          <a:prstGeom prst="rect">
+            <a:avLst/>
+          </a:prstGeom>
+        </p:spPr>
+      </p:pic>
       <p:sp>
         <p:nvSpPr>
           <p:cNvPr id="6" name="TextBox 5"/>
@@ -25396,8 +25919,8 @@
         </p:nvSpPr>
         <p:spPr>
           <a:xfrm>
-            <a:off x="914400" y="1783080"/>
-            <a:ext cx="10728655" cy="2926080"/>
+            <a:off x="7863840" y="1417320"/>
+            <a:ext cx="3779215" cy="4663440"/>
           </a:xfrm>
           <a:prstGeom prst="rect">
             <a:avLst/>
@@ -25405,27 +25928,98 @@
           <a:noFill/>
         </p:spPr>
         <p:txBody>
-          <a:bodyPr wrap="square" anchor="ctr" lIns="45720" rIns="45720" tIns="27432" bIns="27432">
+          <a:bodyPr wrap="square" lIns="45720" rIns="45720">
             <a:spAutoFit/>
           </a:bodyPr>
           <a:lstStyle/>
           <a:p>
-            <a:pPr algn="l"/>
-            <a:r>
-              <a:rPr sz="2800" b="0" i="0">
+            <a:pPr>
+              <a:spcAft>
+                <a:spcPts val="1000"/>
+              </a:spcAft>
+            </a:pPr>
+            <a:r>
+              <a:rPr sz="1800">
                 <a:solidFill>
                   <a:srgbClr val="111111"/>
                 </a:solidFill>
                 <a:latin typeface="Calibri"/>
               </a:rPr>
-              <a:t>It is automating the process as one person thinks it works, then discovering the exceptions three other people quietly handle every week.</a:t>
-            </a:r>
-          </a:p>
-        </p:txBody>
-      </p:sp>
-      <p:sp>
-        <p:nvSpPr>
-          <p:cNvPr id="7" name="Rectangle 6"/>
+              <a:t>•  It is automating the process as one person thinks it works</a:t>
+            </a:r>
+          </a:p>
+          <a:p>
+            <a:pPr>
+              <a:spcAft>
+                <a:spcPts val="1000"/>
+              </a:spcAft>
+            </a:pPr>
+            <a:r>
+              <a:rPr sz="1800">
+                <a:solidFill>
+                  <a:srgbClr val="111111"/>
+                </a:solidFill>
+                <a:latin typeface="Calibri"/>
+              </a:rPr>
+              <a:t>•  Then discovering the exceptions three other people quietly handle every week</a:t>
+            </a:r>
+          </a:p>
+          <a:p>
+            <a:pPr>
+              <a:spcAft>
+                <a:spcPts val="1000"/>
+              </a:spcAft>
+            </a:pPr>
+            <a:r>
+              <a:rPr sz="1800">
+                <a:solidFill>
+                  <a:srgbClr val="111111"/>
+                </a:solidFill>
+                <a:latin typeface="Calibri"/>
+              </a:rPr>
+              <a:t>•  Robots on a car line only work because every step was mapped first</a:t>
+            </a:r>
+          </a:p>
+        </p:txBody>
+      </p:sp>
+      <p:sp>
+        <p:nvSpPr>
+          <p:cNvPr id="7" name="TextBox 6"/>
+          <p:cNvSpPr txBox="1"/>
+          <p:nvPr/>
+        </p:nvSpPr>
+        <p:spPr>
+          <a:xfrm>
+            <a:off x="4785055" y="6016752"/>
+            <a:ext cx="6858000" cy="274320"/>
+          </a:xfrm>
+          <a:prstGeom prst="rect">
+            <a:avLst/>
+          </a:prstGeom>
+          <a:noFill/>
+        </p:spPr>
+        <p:txBody>
+          <a:bodyPr wrap="square" anchor="t" lIns="45720" rIns="45720" tIns="27432" bIns="27432">
+            <a:spAutoFit/>
+          </a:bodyPr>
+          <a:lstStyle/>
+          <a:p>
+            <a:pPr algn="r"/>
+            <a:r>
+              <a:rPr sz="900" b="0" i="1">
+                <a:solidFill>
+                  <a:srgbClr val="666666"/>
+                </a:solidFill>
+                <a:latin typeface="Calibri"/>
+              </a:rPr>
+              <a:t>Photo: Mixabest, Wikimedia Commons, CC BY-SA 3.0</a:t>
+            </a:r>
+          </a:p>
+        </p:txBody>
+      </p:sp>
+      <p:sp>
+        <p:nvSpPr>
+          <p:cNvPr id="8" name="Rectangle 7"/>
           <p:cNvSpPr/>
           <p:nvPr/>
         </p:nvSpPr>
@@ -25469,7 +26063,7 @@
       </p:sp>
       <p:sp>
         <p:nvSpPr>
-          <p:cNvPr id="8" name="TextBox 7"/>
+          <p:cNvPr id="9" name="TextBox 8"/>
           <p:cNvSpPr txBox="1"/>
           <p:nvPr/>
         </p:nvSpPr>
@@ -25504,7 +26098,7 @@
       </p:sp>
       <p:sp>
         <p:nvSpPr>
-          <p:cNvPr id="9" name="TextBox 8"/>
+          <p:cNvPr id="10" name="TextBox 9"/>
           <p:cNvSpPr txBox="1"/>
           <p:nvPr/>
         </p:nvSpPr>
@@ -25745,8 +26339,8 @@
         </p:nvSpPr>
         <p:spPr>
           <a:xfrm>
-            <a:off x="7071055" y="6016752"/>
-            <a:ext cx="4572000" cy="274320"/>
+            <a:off x="4785055" y="6016752"/>
+            <a:ext cx="6858000" cy="274320"/>
           </a:xfrm>
           <a:prstGeom prst="rect">
             <a:avLst/>
@@ -25928,7 +26522,7 @@
           <a:p>
             <a:pPr algn="l"/>
             <a:r>
-              <a:rPr sz="3000" b="1" i="0">
+              <a:rPr sz="2600" b="1" i="0">
                 <a:solidFill>
                   <a:srgbClr val="111111"/>
                 </a:solidFill>
@@ -26027,16 +26621,40 @@
           </a:p>
         </p:txBody>
       </p:sp>
-      <p:sp>
-        <p:nvSpPr>
-          <p:cNvPr id="5" name="TextBox 4"/>
+      <p:pic>
+        <p:nvPicPr>
+          <p:cNvPr id="5" name="Picture 4" descr="slide8_sticky.jpg"/>
+          <p:cNvPicPr>
+            <a:picLocks noChangeAspect="1"/>
+          </p:cNvPicPr>
+          <p:nvPr/>
+        </p:nvPicPr>
+        <p:blipFill>
+          <a:blip r:embed="rId2"/>
+          <a:stretch>
+            <a:fillRect/>
+          </a:stretch>
+        </p:blipFill>
+        <p:spPr>
+          <a:xfrm>
+            <a:off x="1021951" y="1280160"/>
+            <a:ext cx="6002818" cy="4663440"/>
+          </a:xfrm>
+          <a:prstGeom prst="rect">
+            <a:avLst/>
+          </a:prstGeom>
+        </p:spPr>
+      </p:pic>
+      <p:sp>
+        <p:nvSpPr>
+          <p:cNvPr id="6" name="TextBox 5"/>
           <p:cNvSpPr txBox="1"/>
           <p:nvPr/>
         </p:nvSpPr>
         <p:spPr>
           <a:xfrm>
-            <a:off x="548640" y="1371600"/>
-            <a:ext cx="11094415" cy="4937760"/>
+            <a:off x="7863840" y="1417320"/>
+            <a:ext cx="3779215" cy="4663440"/>
           </a:xfrm>
           <a:prstGeom prst="rect">
             <a:avLst/>
@@ -26051,11 +26669,11 @@
           <a:p>
             <a:pPr>
               <a:spcAft>
-                <a:spcPts val="1200"/>
+                <a:spcPts val="1000"/>
               </a:spcAft>
             </a:pPr>
             <a:r>
-              <a:rPr sz="2200">
+              <a:rPr sz="1800">
                 <a:solidFill>
                   <a:srgbClr val="111111"/>
                 </a:solidFill>
@@ -26067,11 +26685,11 @@
           <a:p>
             <a:pPr>
               <a:spcAft>
-                <a:spcPts val="1200"/>
+                <a:spcPts val="1000"/>
               </a:spcAft>
             </a:pPr>
             <a:r>
-              <a:rPr sz="2200">
+              <a:rPr sz="1800">
                 <a:solidFill>
                   <a:srgbClr val="111111"/>
                 </a:solidFill>
@@ -26083,11 +26701,11 @@
           <a:p>
             <a:pPr>
               <a:spcAft>
-                <a:spcPts val="1200"/>
+                <a:spcPts val="1000"/>
               </a:spcAft>
             </a:pPr>
             <a:r>
-              <a:rPr sz="2200">
+              <a:rPr sz="1800">
                 <a:solidFill>
                   <a:srgbClr val="111111"/>
                 </a:solidFill>
@@ -26099,11 +26717,11 @@
           <a:p>
             <a:pPr>
               <a:spcAft>
-                <a:spcPts val="1200"/>
+                <a:spcPts val="1000"/>
               </a:spcAft>
             </a:pPr>
             <a:r>
-              <a:rPr sz="2200">
+              <a:rPr sz="1800">
                 <a:solidFill>
                   <a:srgbClr val="111111"/>
                 </a:solidFill>
@@ -26116,7 +26734,42 @@
       </p:sp>
       <p:sp>
         <p:nvSpPr>
-          <p:cNvPr id="6" name="Rectangle 5"/>
+          <p:cNvPr id="7" name="TextBox 6"/>
+          <p:cNvSpPr txBox="1"/>
+          <p:nvPr/>
+        </p:nvSpPr>
+        <p:spPr>
+          <a:xfrm>
+            <a:off x="4785055" y="6016752"/>
+            <a:ext cx="6858000" cy="274320"/>
+          </a:xfrm>
+          <a:prstGeom prst="rect">
+            <a:avLst/>
+          </a:prstGeom>
+          <a:noFill/>
+        </p:spPr>
+        <p:txBody>
+          <a:bodyPr wrap="square" anchor="t" lIns="45720" rIns="45720" tIns="27432" bIns="27432">
+            <a:spAutoFit/>
+          </a:bodyPr>
+          <a:lstStyle/>
+          <a:p>
+            <a:pPr algn="r"/>
+            <a:r>
+              <a:rPr sz="900" b="0" i="1">
+                <a:solidFill>
+                  <a:srgbClr val="666666"/>
+                </a:solidFill>
+                <a:latin typeface="Calibri"/>
+              </a:rPr>
+              <a:t>Photo: Adrian Grycuk, Wikimedia Commons, CC BY-SA 3.0 PL</a:t>
+            </a:r>
+          </a:p>
+        </p:txBody>
+      </p:sp>
+      <p:sp>
+        <p:nvSpPr>
+          <p:cNvPr id="8" name="Rectangle 7"/>
           <p:cNvSpPr/>
           <p:nvPr/>
         </p:nvSpPr>
@@ -26160,7 +26813,7 @@
       </p:sp>
       <p:sp>
         <p:nvSpPr>
-          <p:cNvPr id="7" name="TextBox 6"/>
+          <p:cNvPr id="9" name="TextBox 8"/>
           <p:cNvSpPr txBox="1"/>
           <p:nvPr/>
         </p:nvSpPr>
@@ -26195,7 +26848,7 @@
       </p:sp>
       <p:sp>
         <p:nvSpPr>
-          <p:cNvPr id="8" name="TextBox 7"/>
+          <p:cNvPr id="10" name="TextBox 9"/>
           <p:cNvSpPr txBox="1"/>
           <p:nvPr/>
         </p:nvSpPr>

</xml_diff>

<commit_message>
AI Administrator Day 2 S3: adapt for online delivery
Breakout rooms instead of pairs, chat and raise-hand instead of hands up, bot link in the
chat alongside the QR, co-instructor moderates; the draw.io and practical videos become the
demo and practical fallbacks; online troubleshooting (dropped connections, silent chat).

Co-Authored-By: Claude Opus 5.5 <noreply@anthropic.com>
</commit_message>
<xml_diff>
--- a/instructor/ai-administrator/out/day2/Day2_S3_Mapping_Current_State.pptx
+++ b/instructor/ai-administrator/out/day2/Day2_S3_Mapping_Current_State.pptx
@@ -617,7 +617,7 @@
           <a:lstStyle/>
           <a:p>
             <a:r>
-              <a:t>Fifteen minutes including the room exercise. Boundaries before boxes.</a:t>
+              <a:t>Fifteen minutes including the breakout exercise. Boundaries before boxes.</a:t>
             </a:r>
           </a:p>
         </p:txBody>
@@ -827,7 +827,7 @@
           <a:lstStyle/>
           <a:p>
             <a:r>
-              <a:t>Expect two different triggers ('stock runs low' versus 'someone emails the office manager'). Good: that is the point of writing the trigger down. Model answer: Suppliers = staff, office manager, vendor; Inputs = request, budget, catalogue; Process = request, check budget, approve, order, receive, distribute; Outputs = delivered items, invoice; Customers = staff, finance. Trigger: a request or a low-stock check. End: items delivered and invoice matched.</a:t>
+              <a:t>Open breakout rooms of two or three for four minutes (the co-instructor sets them up during the SIPOC slide); post the five column names in the chat first. Expect two different triggers ('stock runs low' versus 'someone emails the office manager'). Good: that is the point of writing the trigger down. Model answer: Suppliers = staff, office manager, vendor; Inputs = request, budget, catalogue; Process = request, check budget, approve, order, receive, distribute; Outputs = delivered items, invoice; Customers = staff, finance. Trigger: a request or a low-stock check. End: items delivered and invoice matched.</a:t>
             </a:r>
           </a:p>
         </p:txBody>
@@ -1107,7 +1107,7 @@
           <a:lstStyle/>
           <a:p>
             <a:r>
-              <a:t>About 15 minutes. Follow the demo steps in the instructor guide. Narrate every choice: why the spreadsheet gets a lane, why the decision has two labelled exits, where the email sits. Ask the room for the next step before you draw it. If you run short of time, open the finished file and walk it instead.</a:t>
+              <a:t>About 15 minutes. Follow the demo steps in the instructor guide. Narrate every choice: why the spreadsheet gets a lane, why the decision has two labelled exits, where the email sits. Ask the group to type the next step in the chat before you draw it. If you run short of time, open the finished file and walk it instead.</a:t>
             </a:r>
           </a:p>
         </p:txBody>
@@ -1667,7 +1667,7 @@
           <a:lstStyle/>
           <a:p>
             <a:r>
-              <a:t>Go row by row with an example from the room for each. The fix column previews Session 4 and Day 3. Spend time on RUBBER: approvals that are always given without reading. They feel like control; they are only delay.</a:t>
+              <a:t>Go row by row and ask for an example in the chat for each. The fix column previews Session 4 and Day 3. Spend time on RUBBER: approvals that are always given without reading. They feel like control; they are only delay.</a:t>
             </a:r>
           </a:p>
         </p:txBody>
@@ -1737,7 +1737,7 @@
           <a:lstStyle/>
           <a:p>
             <a:r>
-              <a:t>Ask the room to justify three tags. Why is HR's portal approval RUBBER? Because the manager already decided and HR approves every request. Why is re-entering in the portal REKEY? Because the request already exists in the email. Where is the JUDGE? The manager's decision on clashes: a real decision about the team.</a:t>
+              <a:t>Ask the group to justify three tags in the chat. Why is HR's portal approval RUBBER? Because the manager already decided and HR approves every request. Why is re-entering in the portal REKEY? Because the request already exists in the email. Where is the JUDGE? The manager's decision on clashes: a real decision about the team.</a:t>
             </a:r>
           </a:p>
         </p:txBody>
@@ -2367,7 +2367,7 @@
           <a:lstStyle/>
           <a:p>
             <a:r>
-              <a:t>Three minutes. It is the same @aicaravan_bot as Day 1, switched to the reviewer job for this session (setup guide: aicaravan-bot mapreview). Participants who already chatted with it on Day 1 just send a new message. Pair anyone without Telegram with a neighbour.</a:t>
+              <a:t>Three minutes. It is the same @aicaravan_bot as Day 1, switched to the reviewer job for this session (setup guide: aicaravan-bot mapreview). Participants who already chatted with it on Day 1 just send a new message. Anyone without Telegram follows the instructor's shared screen and uses the prompt in the worksheet with any AI assistant.</a:t>
             </a:r>
           </a:p>
         </p:txBody>
@@ -2437,7 +2437,7 @@
           <a:lstStyle/>
           <a:p>
             <a:r>
-              <a:t>Walk the room. In Task 1 most people will get the department-head approval at quarter end and the missing escalation after three working days; if not, show the next slide. Task 3 should be politely declined.</a:t>
+              <a:t>Watch the chat and ask two participants to share their screen with the bot's answer. In Task 1 most people will get the department-head approval at quarter end and the missing escalation after three working days; if not, show the next slide. Task 3 should be politely declined.</a:t>
             </a:r>
           </a:p>
         </p:txBody>
@@ -2507,7 +2507,7 @@
           <a:lstStyle/>
           <a:p>
             <a:r>
-              <a:t>Five minutes of debrief. Ask for one finding per category from the room. In testing (4 October 2026) the bot found the notice-period, probation and department-head gaps and HR's missing decline path, but missed the three-day escalation. Ask the room what it missed: the answer is in the leave policy, Section 3. That is how you verify an AI reviewer: compare it with a source you trust.</a:t>
+              <a:t>Five minutes of debrief. Ask for one finding per category in the chat. In testing (4 October 2026) the bot found the notice-period, probation and department-head gaps and HR's missing decline path, but missed the three-day escalation. Ask the group what it missed: the answer is in the leave policy, Section 3. That is how you verify an AI reviewer: compare it with a source you trust.</a:t>
             </a:r>
           </a:p>
         </p:txBody>
@@ -3487,7 +3487,7 @@
           <a:lstStyle/>
           <a:p>
             <a:r>
-              <a:t>Ask: who has seen a new system go live and then everyone kept their old spreadsheet anyway? Hands up. That spreadsheet is the real process. Automation freezes what you show it; if you never looked, you freeze the workarounds too, or you break them.</a:t>
+              <a:t>Ask: who has seen a new system go live and then everyone kept their old spreadsheet anyway? Raise-hand reaction, or type 'me' in the chat. That spreadsheet is the real process. Automation freezes what you show it; if you never looked, you freeze the workarounds too, or you break them.</a:t>
             </a:r>
           </a:p>
         </p:txBody>
@@ -8428,7 +8428,7 @@
                 </a:solidFill>
                 <a:latin typeface="Calibri"/>
               </a:rPr>
-              <a:t>Room exercise (5 minutes): SIPOC for ordering office supplies</a:t>
+              <a:t>Breakout exercise (5 minutes): SIPOC for ordering office supplies</a:t>
             </a:r>
           </a:p>
         </p:txBody>
@@ -8604,7 +8604,7 @@
                 </a:solidFill>
                 <a:latin typeface="Calibri"/>
               </a:rPr>
-              <a:t>Pairs</a:t>
+              <a:t>Breakout rooms of two or three</a:t>
             </a:r>
           </a:p>
         </p:txBody>
@@ -8639,7 +8639,7 @@
                 </a:solidFill>
                 <a:latin typeface="Calibri"/>
               </a:rPr>
-              <a:t>Turn to your neighbour. One sheet of paper, five columns.</a:t>
+              <a:t>One person shares a blank doc or sheet with five columns.</a:t>
             </a:r>
           </a:p>
         </p:txBody>
@@ -9140,7 +9140,7 @@
                 </a:solidFill>
                 <a:latin typeface="Calibri"/>
               </a:rPr>
-              <a:t>Two pairs read their trigger aloud. Are they the same?</a:t>
+              <a:t>Back in the main room: every group pastes its trigger in the chat. Are they the same?</a:t>
             </a:r>
           </a:p>
         </p:txBody>
@@ -15633,7 +15633,7 @@
                 </a:solidFill>
                 <a:latin typeface="Calibri"/>
               </a:rPr>
-              <a:t>One leading question is planted. Raise your hand when you hear it.</a:t>
+              <a:t>One leading question is planted. Type 'leading' in the chat when you hear it.</a:t>
             </a:r>
           </a:p>
         </p:txBody>
@@ -17677,7 +17677,7 @@
                 </a:solidFill>
                 <a:latin typeface="Calibri"/>
               </a:rPr>
-              <a:t>1.  Open Telegram on your phone</a:t>
+              <a:t>1.  Click t.me/aicaravan_bot in the chat, or open Telegram on your phone</a:t>
             </a:r>
           </a:p>
           <a:p>
@@ -17693,7 +17693,7 @@
                 </a:solidFill>
                 <a:latin typeface="Calibri"/>
               </a:rPr>
-              <a:t>2.  Scan the code, or search the bot name</a:t>
+              <a:t>2.  Or scan the code on the shared screen</a:t>
             </a:r>
           </a:p>
           <a:p>
@@ -18193,7 +18193,7 @@
                 </a:solidFill>
                 <a:latin typeface="Calibri"/>
               </a:rPr>
-              <a:t>Paste the leave-request step list from the worksheet. Compare its findings with the map on screen.</a:t>
+              <a:t>Paste the leave-request step list from the worksheet. Compare its findings with the map on the shared screen.</a:t>
             </a:r>
           </a:p>
         </p:txBody>
@@ -20185,7 +20185,7 @@
                 </a:solidFill>
                 <a:latin typeface="Calibri"/>
               </a:rPr>
-              <a:t>•  Open kahoot.it on your phone, or the Kahoot app</a:t>
+              <a:t>•  Open kahoot.it on your phone or in a new browser tab</a:t>
             </a:r>
           </a:p>
           <a:p>
@@ -20201,7 +20201,7 @@
                 </a:solidFill>
                 <a:latin typeface="Calibri"/>
               </a:rPr>
-              <a:t>•  Enter the game PIN shown on the screen</a:t>
+              <a:t>•  Enter the game PIN shown on the shared screen</a:t>
             </a:r>
           </a:p>
           <a:p>
@@ -20383,7 +20383,7 @@
                 </a:solidFill>
                 <a:latin typeface="Calibri"/>
               </a:rPr>
-              <a:t>•  We run as many as time allows in the room</a:t>
+              <a:t>•  We run as many as time allows in the session</a:t>
             </a:r>
           </a:p>
           <a:p>
@@ -21259,7 +21259,7 @@
                           </a:solidFill>
                           <a:latin typeface="Calibri"/>
                         </a:rPr>
-                        <a:t>Boundaries, trigger, end state; five-minute room exercise</a:t>
+                        <a:t>Boundaries, trigger, end state; five-minute breakout exercise</a:t>
                       </a:r>
                     </a:p>
                   </a:txBody>

</xml_diff>

<commit_message>
AI Administrator Day 2 S3: Zoom-specific online delivery notes
Co-host role, Zoom settings, Presenter View sharing, video playback with Share sound,
breakout-room timings and broadcast message, Zoom chat for the bot link.

Co-Authored-By: Claude Opus 5.5 <noreply@anthropic.com>
</commit_message>
<xml_diff>
--- a/instructor/ai-administrator/out/day2/Day2_S3_Mapping_Current_State.pptx
+++ b/instructor/ai-administrator/out/day2/Day2_S3_Mapping_Current_State.pptx
@@ -827,7 +827,7 @@
           <a:lstStyle/>
           <a:p>
             <a:r>
-              <a:t>Open breakout rooms of two or three for four minutes (the co-instructor sets them up during the SIPOC slide); post the five column names in the chat first. Expect two different triggers ('stock runs low' versus 'someone emails the office manager'). Good: that is the point of writing the trigger down. Model answer: Suppliers = staff, office manager, vendor; Inputs = request, budget, catalogue; Process = request, check budget, approve, order, receive, distribute; Outputs = delivered items, invoice; Customers = staff, finance. Trigger: a request or a low-stock check. End: items delivered and invoice matched.</a:t>
+              <a:t>The co-host opens Breakout Rooms (assign automatically, 2 to 3 people each, close automatically after 4 minutes with a 30-second countdown) during the SIPOC slide; post the five column names in the chat first, and use 'Broadcast message to all rooms' at minute 3 ('one minute left: write your trigger'). Expect two different triggers ('stock runs low' versus 'someone emails the office manager'). Good: that is the point of writing the trigger down. Model answer: Suppliers = staff, office manager, vendor; Inputs = request, budget, catalogue; Process = request, check budget, approve, order, receive, distribute; Outputs = delivered items, invoice; Customers = staff, finance. Trigger: a request or a low-stock check. End: items delivered and invoice matched.</a:t>
             </a:r>
           </a:p>
         </p:txBody>
@@ -3487,7 +3487,7 @@
           <a:lstStyle/>
           <a:p>
             <a:r>
-              <a:t>Ask: who has seen a new system go live and then everyone kept their old spreadsheet anyway? Raise-hand reaction, or type 'me' in the chat. That spreadsheet is the real process. Automation freezes what you show it; if you never looked, you freeze the workarounds too, or you break them.</a:t>
+              <a:t>Ask: who has seen a new system go live and then everyone kept their old spreadsheet anyway? Raise Hand in Zoom Reactions, or type 'me' in the chat. That spreadsheet is the real process. Automation freezes what you show it; if you never looked, you freeze the workarounds too, or you break them.</a:t>
             </a:r>
           </a:p>
         </p:txBody>
@@ -8639,7 +8639,7 @@
                 </a:solidFill>
                 <a:latin typeface="Calibri"/>
               </a:rPr>
-              <a:t>One person shares a blank doc or sheet with five columns.</a:t>
+              <a:t>Zoom breakout rooms. One person shares screen with a blank doc or sheet, five columns.</a:t>
             </a:r>
           </a:p>
         </p:txBody>

</xml_diff>